<commit_message>
presentacion, viñeta de valores atipicos
</commit_message>
<xml_diff>
--- a/Presentation1.pptx
+++ b/Presentation1.pptx
@@ -19,9 +19,10 @@
     <p:sldId id="266" r:id="rId13"/>
     <p:sldId id="273" r:id="rId14"/>
     <p:sldId id="267" r:id="rId15"/>
-    <p:sldId id="268" r:id="rId16"/>
-    <p:sldId id="257" r:id="rId17"/>
-    <p:sldId id="328" r:id="rId18"/>
+    <p:sldId id="329" r:id="rId16"/>
+    <p:sldId id="268" r:id="rId17"/>
+    <p:sldId id="257" r:id="rId18"/>
+    <p:sldId id="328" r:id="rId19"/>
   </p:sldIdLst>
   <p:sldSz cx="12192000" cy="6858000"/>
   <p:notesSz cx="6858000" cy="9144000"/>
@@ -277,7 +278,7 @@
           <a:p>
             <a:fld id="{E19202B3-1060-482B-973A-1D7C2D430671}" type="datetimeFigureOut">
               <a:rPr lang="es-ES" smtClean="0"/>
-              <a:t>13/09/2026</a:t>
+              <a:t>16/09/2026</a:t>
             </a:fld>
             <a:endParaRPr lang="es-ES"/>
           </a:p>
@@ -477,7 +478,7 @@
           <a:p>
             <a:fld id="{E19202B3-1060-482B-973A-1D7C2D430671}" type="datetimeFigureOut">
               <a:rPr lang="es-ES" smtClean="0"/>
-              <a:t>13/09/2026</a:t>
+              <a:t>16/09/2026</a:t>
             </a:fld>
             <a:endParaRPr lang="es-ES"/>
           </a:p>
@@ -687,7 +688,7 @@
           <a:p>
             <a:fld id="{E19202B3-1060-482B-973A-1D7C2D430671}" type="datetimeFigureOut">
               <a:rPr lang="es-ES" smtClean="0"/>
-              <a:t>13/09/2026</a:t>
+              <a:t>16/09/2026</a:t>
             </a:fld>
             <a:endParaRPr lang="es-ES"/>
           </a:p>
@@ -887,7 +888,7 @@
           <a:p>
             <a:fld id="{E19202B3-1060-482B-973A-1D7C2D430671}" type="datetimeFigureOut">
               <a:rPr lang="es-ES" smtClean="0"/>
-              <a:t>13/09/2026</a:t>
+              <a:t>16/09/2026</a:t>
             </a:fld>
             <a:endParaRPr lang="es-ES"/>
           </a:p>
@@ -1163,7 +1164,7 @@
           <a:p>
             <a:fld id="{E19202B3-1060-482B-973A-1D7C2D430671}" type="datetimeFigureOut">
               <a:rPr lang="es-ES" smtClean="0"/>
-              <a:t>13/09/2026</a:t>
+              <a:t>16/09/2026</a:t>
             </a:fld>
             <a:endParaRPr lang="es-ES"/>
           </a:p>
@@ -1431,7 +1432,7 @@
           <a:p>
             <a:fld id="{E19202B3-1060-482B-973A-1D7C2D430671}" type="datetimeFigureOut">
               <a:rPr lang="es-ES" smtClean="0"/>
-              <a:t>13/09/2026</a:t>
+              <a:t>16/09/2026</a:t>
             </a:fld>
             <a:endParaRPr lang="es-ES"/>
           </a:p>
@@ -1846,7 +1847,7 @@
           <a:p>
             <a:fld id="{E19202B3-1060-482B-973A-1D7C2D430671}" type="datetimeFigureOut">
               <a:rPr lang="es-ES" smtClean="0"/>
-              <a:t>13/09/2026</a:t>
+              <a:t>16/09/2026</a:t>
             </a:fld>
             <a:endParaRPr lang="es-ES"/>
           </a:p>
@@ -1988,7 +1989,7 @@
           <a:p>
             <a:fld id="{E19202B3-1060-482B-973A-1D7C2D430671}" type="datetimeFigureOut">
               <a:rPr lang="es-ES" smtClean="0"/>
-              <a:t>13/09/2026</a:t>
+              <a:t>16/09/2026</a:t>
             </a:fld>
             <a:endParaRPr lang="es-ES"/>
           </a:p>
@@ -2101,7 +2102,7 @@
           <a:p>
             <a:fld id="{E19202B3-1060-482B-973A-1D7C2D430671}" type="datetimeFigureOut">
               <a:rPr lang="es-ES" smtClean="0"/>
-              <a:t>13/09/2026</a:t>
+              <a:t>16/09/2026</a:t>
             </a:fld>
             <a:endParaRPr lang="es-ES"/>
           </a:p>
@@ -2414,7 +2415,7 @@
           <a:p>
             <a:fld id="{E19202B3-1060-482B-973A-1D7C2D430671}" type="datetimeFigureOut">
               <a:rPr lang="es-ES" smtClean="0"/>
-              <a:t>13/09/2026</a:t>
+              <a:t>16/09/2026</a:t>
             </a:fld>
             <a:endParaRPr lang="es-ES"/>
           </a:p>
@@ -2703,7 +2704,7 @@
           <a:p>
             <a:fld id="{E19202B3-1060-482B-973A-1D7C2D430671}" type="datetimeFigureOut">
               <a:rPr lang="es-ES" smtClean="0"/>
-              <a:t>13/09/2026</a:t>
+              <a:t>16/09/2026</a:t>
             </a:fld>
             <a:endParaRPr lang="es-ES"/>
           </a:p>
@@ -2946,7 +2947,7 @@
           <a:p>
             <a:fld id="{E19202B3-1060-482B-973A-1D7C2D430671}" type="datetimeFigureOut">
               <a:rPr lang="es-ES" smtClean="0"/>
-              <a:t>13/09/2026</a:t>
+              <a:t>16/09/2026</a:t>
             </a:fld>
             <a:endParaRPr lang="es-ES"/>
           </a:p>
@@ -5924,6 +5925,2009 @@
   <p:cSld>
     <p:spTree>
       <p:nvGrpSpPr>
+        <p:cNvPr id="1" name=""/>
+        <p:cNvGrpSpPr/>
+        <p:nvPr/>
+      </p:nvGrpSpPr>
+      <p:grpSpPr>
+        <a:xfrm>
+          <a:off x="0" y="0"/>
+          <a:ext cx="0" cy="0"/>
+          <a:chOff x="0" y="0"/>
+          <a:chExt cx="0" cy="0"/>
+        </a:xfrm>
+      </p:grpSpPr>
+      <p:cxnSp>
+        <p:nvCxnSpPr>
+          <p:cNvPr id="4" name="Straight Connector 3">
+            <a:extLst>
+              <a:ext uri="{FF2B5EF4-FFF2-40B4-BE49-F238E27FC236}">
+                <a16:creationId xmlns:a16="http://schemas.microsoft.com/office/drawing/2014/main" id="{C3FAF3D5-2257-1478-4045-D04C42639BCD}"/>
+              </a:ext>
+            </a:extLst>
+          </p:cNvPr>
+          <p:cNvCxnSpPr>
+            <a:cxnSpLocks/>
+          </p:cNvCxnSpPr>
+          <p:nvPr/>
+        </p:nvCxnSpPr>
+        <p:spPr>
+          <a:xfrm>
+            <a:off x="209550" y="893763"/>
+            <a:ext cx="12028362" cy="0"/>
+          </a:xfrm>
+          <a:prstGeom prst="line">
+            <a:avLst/>
+          </a:prstGeom>
+          <a:ln>
+            <a:solidFill>
+              <a:schemeClr val="accent5"/>
+            </a:solidFill>
+          </a:ln>
+        </p:spPr>
+        <p:style>
+          <a:lnRef idx="1">
+            <a:schemeClr val="accent1"/>
+          </a:lnRef>
+          <a:fillRef idx="0">
+            <a:schemeClr val="accent1"/>
+          </a:fillRef>
+          <a:effectRef idx="0">
+            <a:schemeClr val="accent1"/>
+          </a:effectRef>
+          <a:fontRef idx="minor">
+            <a:schemeClr val="tx1"/>
+          </a:fontRef>
+        </p:style>
+      </p:cxnSp>
+      <p:sp>
+        <p:nvSpPr>
+          <p:cNvPr id="5" name="Rectangle: Diagonal Corners Snipped 4">
+            <a:extLst>
+              <a:ext uri="{FF2B5EF4-FFF2-40B4-BE49-F238E27FC236}">
+                <a16:creationId xmlns:a16="http://schemas.microsoft.com/office/drawing/2014/main" id="{9C60D945-BDAD-CC24-6AD9-04A61E931932}"/>
+              </a:ext>
+            </a:extLst>
+          </p:cNvPr>
+          <p:cNvSpPr/>
+          <p:nvPr/>
+        </p:nvSpPr>
+        <p:spPr>
+          <a:xfrm>
+            <a:off x="0" y="0"/>
+            <a:ext cx="6705600" cy="903288"/>
+          </a:xfrm>
+          <a:prstGeom prst="snip2DiagRect">
+            <a:avLst/>
+          </a:prstGeom>
+          <a:solidFill>
+            <a:schemeClr val="accent5"/>
+          </a:solidFill>
+          <a:ln>
+            <a:noFill/>
+          </a:ln>
+          <a:effectLst>
+            <a:outerShdw blurRad="50800" dist="38100" dir="2700000" algn="tl" rotWithShape="0">
+              <a:prstClr val="black">
+                <a:alpha val="40000"/>
+              </a:prstClr>
+            </a:outerShdw>
+          </a:effectLst>
+        </p:spPr>
+        <p:style>
+          <a:lnRef idx="2">
+            <a:schemeClr val="accent5">
+              <a:shade val="15000"/>
+            </a:schemeClr>
+          </a:lnRef>
+          <a:fillRef idx="1">
+            <a:schemeClr val="accent5"/>
+          </a:fillRef>
+          <a:effectRef idx="0">
+            <a:schemeClr val="accent5"/>
+          </a:effectRef>
+          <a:fontRef idx="minor">
+            <a:schemeClr val="lt1"/>
+          </a:fontRef>
+        </p:style>
+        <p:txBody>
+          <a:bodyPr rtlCol="0" anchor="ctr"/>
+          <a:lstStyle/>
+          <a:p>
+            <a:pPr algn="ctr"/>
+            <a:r>
+              <a:rPr lang="es-ES" sz="3600" b="1" dirty="0">
+                <a:latin typeface="Atkinson Hyperlegible" pitchFamily="2" charset="0"/>
+              </a:rPr>
+              <a:t>VALORES ATÍPICOS</a:t>
+            </a:r>
+            <a:endParaRPr lang="es-ES" sz="3600" b="1" dirty="0"/>
+          </a:p>
+        </p:txBody>
+      </p:sp>
+      <p:pic>
+        <p:nvPicPr>
+          <p:cNvPr id="9" name="Picture 8">
+            <a:extLst>
+              <a:ext uri="{FF2B5EF4-FFF2-40B4-BE49-F238E27FC236}">
+                <a16:creationId xmlns:a16="http://schemas.microsoft.com/office/drawing/2014/main" id="{0AC3542C-AB5C-18E0-C0CF-D8A5C71701F0}"/>
+              </a:ext>
+            </a:extLst>
+          </p:cNvPr>
+          <p:cNvPicPr>
+            <a:picLocks/>
+          </p:cNvPicPr>
+          <p:nvPr/>
+        </p:nvPicPr>
+        <p:blipFill>
+          <a:blip r:embed="rId2"/>
+          <a:stretch>
+            <a:fillRect/>
+          </a:stretch>
+        </p:blipFill>
+        <p:spPr>
+          <a:xfrm>
+            <a:off x="9091685" y="3337982"/>
+            <a:ext cx="2699697" cy="1620000"/>
+          </a:xfrm>
+          <a:prstGeom prst="rect">
+            <a:avLst/>
+          </a:prstGeom>
+          <a:effectLst>
+            <a:outerShdw blurRad="50800" dist="38100" dir="2700000" algn="tl" rotWithShape="0">
+              <a:prstClr val="black">
+                <a:alpha val="40000"/>
+              </a:prstClr>
+            </a:outerShdw>
+          </a:effectLst>
+        </p:spPr>
+      </p:pic>
+      <p:pic>
+        <p:nvPicPr>
+          <p:cNvPr id="10" name="Picture 9">
+            <a:extLst>
+              <a:ext uri="{FF2B5EF4-FFF2-40B4-BE49-F238E27FC236}">
+                <a16:creationId xmlns:a16="http://schemas.microsoft.com/office/drawing/2014/main" id="{5A4980CE-5158-8131-B9A6-15AC420EFF49}"/>
+              </a:ext>
+            </a:extLst>
+          </p:cNvPr>
+          <p:cNvPicPr>
+            <a:picLocks/>
+          </p:cNvPicPr>
+          <p:nvPr/>
+        </p:nvPicPr>
+        <p:blipFill>
+          <a:blip r:embed="rId3"/>
+          <a:stretch>
+            <a:fillRect/>
+          </a:stretch>
+        </p:blipFill>
+        <p:spPr>
+          <a:xfrm>
+            <a:off x="716671" y="3337982"/>
+            <a:ext cx="2700000" cy="1620000"/>
+          </a:xfrm>
+          <a:prstGeom prst="rect">
+            <a:avLst/>
+          </a:prstGeom>
+          <a:effectLst>
+            <a:outerShdw blurRad="50800" dist="38100" dir="2700000" algn="tl" rotWithShape="0">
+              <a:prstClr val="black">
+                <a:alpha val="40000"/>
+              </a:prstClr>
+            </a:outerShdw>
+          </a:effectLst>
+        </p:spPr>
+      </p:pic>
+      <p:pic>
+        <p:nvPicPr>
+          <p:cNvPr id="11" name="Picture 10">
+            <a:extLst>
+              <a:ext uri="{FF2B5EF4-FFF2-40B4-BE49-F238E27FC236}">
+                <a16:creationId xmlns:a16="http://schemas.microsoft.com/office/drawing/2014/main" id="{FC5BB54D-7D31-8457-3E43-8DBC75B9CD21}"/>
+              </a:ext>
+            </a:extLst>
+          </p:cNvPr>
+          <p:cNvPicPr>
+            <a:picLocks/>
+          </p:cNvPicPr>
+          <p:nvPr/>
+        </p:nvPicPr>
+        <p:blipFill>
+          <a:blip r:embed="rId4"/>
+          <a:stretch>
+            <a:fillRect/>
+          </a:stretch>
+        </p:blipFill>
+        <p:spPr>
+          <a:xfrm>
+            <a:off x="4548831" y="3337982"/>
+            <a:ext cx="2700000" cy="1620000"/>
+          </a:xfrm>
+          <a:prstGeom prst="rect">
+            <a:avLst/>
+          </a:prstGeom>
+          <a:effectLst>
+            <a:outerShdw blurRad="50800" dist="38100" dir="2700000" algn="tl" rotWithShape="0">
+              <a:prstClr val="black">
+                <a:alpha val="40000"/>
+              </a:prstClr>
+            </a:outerShdw>
+          </a:effectLst>
+        </p:spPr>
+      </p:pic>
+      <p:sp>
+        <p:nvSpPr>
+          <p:cNvPr id="12" name="Cross 11">
+            <a:extLst>
+              <a:ext uri="{FF2B5EF4-FFF2-40B4-BE49-F238E27FC236}">
+                <a16:creationId xmlns:a16="http://schemas.microsoft.com/office/drawing/2014/main" id="{F1643B5A-2F64-C831-62CD-ABF07ED3FC42}"/>
+              </a:ext>
+            </a:extLst>
+          </p:cNvPr>
+          <p:cNvSpPr/>
+          <p:nvPr/>
+        </p:nvSpPr>
+        <p:spPr>
+          <a:xfrm>
+            <a:off x="3672122" y="3860221"/>
+            <a:ext cx="601709" cy="605440"/>
+          </a:xfrm>
+          <a:prstGeom prst="plus">
+            <a:avLst>
+              <a:gd name="adj" fmla="val 40466"/>
+            </a:avLst>
+          </a:prstGeom>
+          <a:solidFill>
+            <a:schemeClr val="accent4"/>
+          </a:solidFill>
+          <a:ln>
+            <a:noFill/>
+          </a:ln>
+          <a:effectLst>
+            <a:outerShdw blurRad="50800" dist="38100" dir="2700000" algn="tl" rotWithShape="0">
+              <a:prstClr val="black">
+                <a:alpha val="40000"/>
+              </a:prstClr>
+            </a:outerShdw>
+          </a:effectLst>
+        </p:spPr>
+        <p:style>
+          <a:lnRef idx="3">
+            <a:schemeClr val="lt1"/>
+          </a:lnRef>
+          <a:fillRef idx="1">
+            <a:schemeClr val="accent4"/>
+          </a:fillRef>
+          <a:effectRef idx="1">
+            <a:schemeClr val="accent4"/>
+          </a:effectRef>
+          <a:fontRef idx="minor">
+            <a:schemeClr val="lt1"/>
+          </a:fontRef>
+        </p:style>
+        <p:txBody>
+          <a:bodyPr rtlCol="0" anchor="ctr"/>
+          <a:lstStyle/>
+          <a:p>
+            <a:pPr algn="ctr"/>
+            <a:endParaRPr lang="es-ES" sz="2800" b="1">
+              <a:latin typeface="Atkinson Hyperlegible" pitchFamily="2" charset="0"/>
+            </a:endParaRPr>
+          </a:p>
+        </p:txBody>
+      </p:sp>
+      <p:sp>
+        <p:nvSpPr>
+          <p:cNvPr id="13" name="Rectangle 12">
+            <a:extLst>
+              <a:ext uri="{FF2B5EF4-FFF2-40B4-BE49-F238E27FC236}">
+                <a16:creationId xmlns:a16="http://schemas.microsoft.com/office/drawing/2014/main" id="{80B456CA-845A-2400-D6E3-4FF02B6A7199}"/>
+              </a:ext>
+            </a:extLst>
+          </p:cNvPr>
+          <p:cNvSpPr/>
+          <p:nvPr/>
+        </p:nvSpPr>
+        <p:spPr>
+          <a:xfrm>
+            <a:off x="7890802" y="4237958"/>
+            <a:ext cx="609600" cy="173182"/>
+          </a:xfrm>
+          <a:prstGeom prst="rect">
+            <a:avLst/>
+          </a:prstGeom>
+          <a:solidFill>
+            <a:schemeClr val="accent4"/>
+          </a:solidFill>
+          <a:ln>
+            <a:noFill/>
+          </a:ln>
+          <a:effectLst>
+            <a:outerShdw blurRad="50800" dist="38100" dir="2700000" algn="tl" rotWithShape="0">
+              <a:prstClr val="black">
+                <a:alpha val="40000"/>
+              </a:prstClr>
+            </a:outerShdw>
+          </a:effectLst>
+        </p:spPr>
+        <p:style>
+          <a:lnRef idx="3">
+            <a:schemeClr val="lt1"/>
+          </a:lnRef>
+          <a:fillRef idx="1">
+            <a:schemeClr val="accent4"/>
+          </a:fillRef>
+          <a:effectRef idx="1">
+            <a:schemeClr val="accent4"/>
+          </a:effectRef>
+          <a:fontRef idx="minor">
+            <a:schemeClr val="lt1"/>
+          </a:fontRef>
+        </p:style>
+        <p:txBody>
+          <a:bodyPr rtlCol="0" anchor="ctr"/>
+          <a:lstStyle/>
+          <a:p>
+            <a:pPr algn="ctr"/>
+            <a:endParaRPr lang="es-ES" sz="2800" b="1">
+              <a:latin typeface="Atkinson Hyperlegible" pitchFamily="2" charset="0"/>
+            </a:endParaRPr>
+          </a:p>
+        </p:txBody>
+      </p:sp>
+      <p:sp>
+        <p:nvSpPr>
+          <p:cNvPr id="14" name="Rectangle 13">
+            <a:extLst>
+              <a:ext uri="{FF2B5EF4-FFF2-40B4-BE49-F238E27FC236}">
+                <a16:creationId xmlns:a16="http://schemas.microsoft.com/office/drawing/2014/main" id="{F1AE93B4-435D-EEE7-26F9-F26B7A1E85E5}"/>
+              </a:ext>
+            </a:extLst>
+          </p:cNvPr>
+          <p:cNvSpPr/>
+          <p:nvPr/>
+        </p:nvSpPr>
+        <p:spPr>
+          <a:xfrm>
+            <a:off x="7886189" y="3983961"/>
+            <a:ext cx="609600" cy="173182"/>
+          </a:xfrm>
+          <a:prstGeom prst="rect">
+            <a:avLst/>
+          </a:prstGeom>
+          <a:solidFill>
+            <a:schemeClr val="accent4"/>
+          </a:solidFill>
+          <a:ln>
+            <a:noFill/>
+          </a:ln>
+          <a:effectLst>
+            <a:outerShdw blurRad="50800" dist="38100" dir="2700000" algn="tl" rotWithShape="0">
+              <a:prstClr val="black">
+                <a:alpha val="40000"/>
+              </a:prstClr>
+            </a:outerShdw>
+          </a:effectLst>
+        </p:spPr>
+        <p:style>
+          <a:lnRef idx="3">
+            <a:schemeClr val="lt1"/>
+          </a:lnRef>
+          <a:fillRef idx="1">
+            <a:schemeClr val="accent4"/>
+          </a:fillRef>
+          <a:effectRef idx="1">
+            <a:schemeClr val="accent4"/>
+          </a:effectRef>
+          <a:fontRef idx="minor">
+            <a:schemeClr val="lt1"/>
+          </a:fontRef>
+        </p:style>
+        <p:txBody>
+          <a:bodyPr rtlCol="0" anchor="ctr"/>
+          <a:lstStyle/>
+          <a:p>
+            <a:pPr algn="ctr"/>
+            <a:endParaRPr lang="es-ES" sz="2800" b="1">
+              <a:latin typeface="Atkinson Hyperlegible" pitchFamily="2" charset="0"/>
+            </a:endParaRPr>
+          </a:p>
+        </p:txBody>
+      </p:sp>
+      <mc:AlternateContent xmlns:mc="http://schemas.openxmlformats.org/markup-compatibility/2006">
+        <mc:Choice xmlns:a14="http://schemas.microsoft.com/office/drawing/2010/main" Requires="a14">
+          <p:sp>
+            <p:nvSpPr>
+              <p:cNvPr id="15" name="TextBox 14">
+                <a:extLst>
+                  <a:ext uri="{FF2B5EF4-FFF2-40B4-BE49-F238E27FC236}">
+                    <a16:creationId xmlns:a16="http://schemas.microsoft.com/office/drawing/2014/main" id="{A4F4FE7F-51DE-202D-D8F8-02FD123F3526}"/>
+                  </a:ext>
+                </a:extLst>
+              </p:cNvPr>
+              <p:cNvSpPr txBox="1"/>
+              <p:nvPr/>
+            </p:nvSpPr>
+            <p:spPr>
+              <a:xfrm>
+                <a:off x="3672122" y="1654384"/>
+                <a:ext cx="5395643" cy="276999"/>
+              </a:xfrm>
+              <a:prstGeom prst="rect">
+                <a:avLst/>
+              </a:prstGeom>
+              <a:noFill/>
+            </p:spPr>
+            <p:txBody>
+              <a:bodyPr wrap="none" lIns="0" tIns="0" rIns="0" bIns="0" rtlCol="0">
+                <a:spAutoFit/>
+              </a:bodyPr>
+              <a:lstStyle/>
+              <a:p>
+                <a:pPr/>
+                <a14:m>
+                  <m:oMathPara xmlns:m="http://schemas.openxmlformats.org/officeDocument/2006/math">
+                    <m:oMathParaPr>
+                      <m:jc m:val="centerGroup"/>
+                    </m:oMathParaPr>
+                    <m:oMath xmlns:m="http://schemas.openxmlformats.org/officeDocument/2006/math">
+                      <m:sSub>
+                        <m:sSubPr>
+                          <m:ctrlPr>
+                            <a:rPr lang="es-ES" b="1" i="1" smtClean="0">
+                              <a:latin typeface="Cambria Math" panose="02040503050406030204" pitchFamily="18" charset="0"/>
+                            </a:rPr>
+                          </m:ctrlPr>
+                        </m:sSubPr>
+                        <m:e>
+                          <m:r>
+                            <a:rPr lang="es-ES" b="1" i="1" smtClean="0">
+                              <a:latin typeface="Cambria Math" panose="02040503050406030204" pitchFamily="18" charset="0"/>
+                            </a:rPr>
+                            <m:t>𝒘</m:t>
+                          </m:r>
+                        </m:e>
+                        <m:sub>
+                          <m:r>
+                            <a:rPr lang="es-ES" b="1" i="1" smtClean="0">
+                              <a:latin typeface="Cambria Math" panose="02040503050406030204" pitchFamily="18" charset="0"/>
+                            </a:rPr>
+                            <m:t>𝟏</m:t>
+                          </m:r>
+                        </m:sub>
+                      </m:sSub>
+                      <m:r>
+                        <a:rPr lang="es-ES" b="1" i="1" smtClean="0">
+                          <a:latin typeface="Cambria Math" panose="02040503050406030204" pitchFamily="18" charset="0"/>
+                        </a:rPr>
+                        <m:t> </m:t>
+                      </m:r>
+                      <m:r>
+                        <a:rPr lang="es-ES" b="1" i="1" smtClean="0">
+                          <a:latin typeface="Cambria Math" panose="02040503050406030204" pitchFamily="18" charset="0"/>
+                        </a:rPr>
+                        <m:t>𝝓</m:t>
+                      </m:r>
+                      <m:d>
+                        <m:dPr>
+                          <m:ctrlPr>
+                            <a:rPr lang="es-ES" b="1" i="1" smtClean="0">
+                              <a:latin typeface="Cambria Math" panose="02040503050406030204" pitchFamily="18" charset="0"/>
+                            </a:rPr>
+                          </m:ctrlPr>
+                        </m:dPr>
+                        <m:e>
+                          <m:r>
+                            <a:rPr lang="es-ES" b="1" i="1" smtClean="0">
+                              <a:latin typeface="Cambria Math" panose="02040503050406030204" pitchFamily="18" charset="0"/>
+                            </a:rPr>
+                            <m:t> </m:t>
+                          </m:r>
+                          <m:r>
+                            <a:rPr lang="es-ES" b="1" i="1" smtClean="0">
+                              <a:latin typeface="Cambria Math" panose="02040503050406030204" pitchFamily="18" charset="0"/>
+                            </a:rPr>
+                            <m:t>𝑿</m:t>
+                          </m:r>
+                          <m:r>
+                            <a:rPr lang="es-ES" b="1" i="1" smtClean="0">
+                              <a:latin typeface="Cambria Math" panose="02040503050406030204" pitchFamily="18" charset="0"/>
+                            </a:rPr>
+                            <m:t>, </m:t>
+                          </m:r>
+                          <m:r>
+                            <a:rPr lang="es-ES" b="1" i="1" smtClean="0">
+                              <a:latin typeface="Cambria Math" panose="02040503050406030204" pitchFamily="18" charset="0"/>
+                            </a:rPr>
+                            <m:t>𝝁</m:t>
+                          </m:r>
+                          <m:r>
+                            <a:rPr lang="es-ES" b="1" i="1" smtClean="0">
+                              <a:latin typeface="Cambria Math" panose="02040503050406030204" pitchFamily="18" charset="0"/>
+                            </a:rPr>
+                            <m:t>=</m:t>
+                          </m:r>
+                          <m:r>
+                            <a:rPr lang="es-ES" b="1" i="1" smtClean="0">
+                              <a:latin typeface="Cambria Math" panose="02040503050406030204" pitchFamily="18" charset="0"/>
+                            </a:rPr>
+                            <m:t>𝟎</m:t>
+                          </m:r>
+                          <m:r>
+                            <a:rPr lang="es-ES" b="1" i="1" smtClean="0">
+                              <a:latin typeface="Cambria Math" panose="02040503050406030204" pitchFamily="18" charset="0"/>
+                            </a:rPr>
+                            <m:t>, </m:t>
+                          </m:r>
+                          <m:r>
+                            <a:rPr lang="es-ES" b="1" i="1" smtClean="0">
+                              <a:latin typeface="Cambria Math" panose="02040503050406030204" pitchFamily="18" charset="0"/>
+                            </a:rPr>
+                            <m:t>𝝈</m:t>
+                          </m:r>
+                          <m:r>
+                            <a:rPr lang="es-ES" b="1" i="1" smtClean="0">
+                              <a:latin typeface="Cambria Math" panose="02040503050406030204" pitchFamily="18" charset="0"/>
+                            </a:rPr>
+                            <m:t>=</m:t>
+                          </m:r>
+                          <m:r>
+                            <a:rPr lang="es-ES" b="1" i="1" smtClean="0">
+                              <a:latin typeface="Cambria Math" panose="02040503050406030204" pitchFamily="18" charset="0"/>
+                            </a:rPr>
+                            <m:t>𝟒</m:t>
+                          </m:r>
+                        </m:e>
+                      </m:d>
+                      <m:r>
+                        <a:rPr lang="es-ES" b="1" i="1" smtClean="0">
+                          <a:latin typeface="Cambria Math" panose="02040503050406030204" pitchFamily="18" charset="0"/>
+                        </a:rPr>
+                        <m:t>   +   </m:t>
+                      </m:r>
+                      <m:sSub>
+                        <m:sSubPr>
+                          <m:ctrlPr>
+                            <a:rPr lang="es-ES" b="1" i="1" smtClean="0">
+                              <a:latin typeface="Cambria Math" panose="02040503050406030204" pitchFamily="18" charset="0"/>
+                            </a:rPr>
+                          </m:ctrlPr>
+                        </m:sSubPr>
+                        <m:e>
+                          <m:r>
+                            <a:rPr lang="es-ES" b="1" i="1" smtClean="0">
+                              <a:latin typeface="Cambria Math" panose="02040503050406030204" pitchFamily="18" charset="0"/>
+                            </a:rPr>
+                            <m:t>𝒘</m:t>
+                          </m:r>
+                        </m:e>
+                        <m:sub>
+                          <m:r>
+                            <a:rPr lang="es-ES" b="1" i="1" smtClean="0">
+                              <a:latin typeface="Cambria Math" panose="02040503050406030204" pitchFamily="18" charset="0"/>
+                            </a:rPr>
+                            <m:t>𝟐</m:t>
+                          </m:r>
+                        </m:sub>
+                      </m:sSub>
+                      <m:r>
+                        <a:rPr lang="es-ES" b="1" i="1" smtClean="0">
+                          <a:latin typeface="Cambria Math" panose="02040503050406030204" pitchFamily="18" charset="0"/>
+                        </a:rPr>
+                        <m:t> </m:t>
+                      </m:r>
+                      <m:r>
+                        <a:rPr lang="es-ES" b="1" i="1" smtClean="0">
+                          <a:latin typeface="Cambria Math" panose="02040503050406030204" pitchFamily="18" charset="0"/>
+                        </a:rPr>
+                        <m:t>𝝓</m:t>
+                      </m:r>
+                      <m:d>
+                        <m:dPr>
+                          <m:ctrlPr>
+                            <a:rPr lang="es-ES" b="1" i="1" smtClean="0">
+                              <a:latin typeface="Cambria Math" panose="02040503050406030204" pitchFamily="18" charset="0"/>
+                            </a:rPr>
+                          </m:ctrlPr>
+                        </m:dPr>
+                        <m:e>
+                          <m:r>
+                            <a:rPr lang="es-ES" b="1" i="1" smtClean="0">
+                              <a:latin typeface="Cambria Math" panose="02040503050406030204" pitchFamily="18" charset="0"/>
+                            </a:rPr>
+                            <m:t> </m:t>
+                          </m:r>
+                          <m:r>
+                            <a:rPr lang="es-ES" b="1" i="1" smtClean="0">
+                              <a:latin typeface="Cambria Math" panose="02040503050406030204" pitchFamily="18" charset="0"/>
+                            </a:rPr>
+                            <m:t>𝑿</m:t>
+                          </m:r>
+                          <m:r>
+                            <a:rPr lang="es-ES" b="1" i="1" smtClean="0">
+                              <a:latin typeface="Cambria Math" panose="02040503050406030204" pitchFamily="18" charset="0"/>
+                            </a:rPr>
+                            <m:t>, </m:t>
+                          </m:r>
+                          <m:r>
+                            <a:rPr lang="es-ES" b="1" i="1" smtClean="0">
+                              <a:latin typeface="Cambria Math" panose="02040503050406030204" pitchFamily="18" charset="0"/>
+                            </a:rPr>
+                            <m:t>𝝁</m:t>
+                          </m:r>
+                          <m:r>
+                            <a:rPr lang="es-ES" b="1" i="1" smtClean="0">
+                              <a:latin typeface="Cambria Math" panose="02040503050406030204" pitchFamily="18" charset="0"/>
+                            </a:rPr>
+                            <m:t>=</m:t>
+                          </m:r>
+                          <m:r>
+                            <a:rPr lang="es-ES" b="1" i="1" smtClean="0">
+                              <a:latin typeface="Cambria Math" panose="02040503050406030204" pitchFamily="18" charset="0"/>
+                            </a:rPr>
+                            <m:t>𝟎</m:t>
+                          </m:r>
+                          <m:r>
+                            <a:rPr lang="es-ES" b="1" i="1" smtClean="0">
+                              <a:latin typeface="Cambria Math" panose="02040503050406030204" pitchFamily="18" charset="0"/>
+                            </a:rPr>
+                            <m:t>, </m:t>
+                          </m:r>
+                          <m:r>
+                            <a:rPr lang="es-ES" b="1" i="1" smtClean="0">
+                              <a:latin typeface="Cambria Math" panose="02040503050406030204" pitchFamily="18" charset="0"/>
+                            </a:rPr>
+                            <m:t>𝝈</m:t>
+                          </m:r>
+                          <m:r>
+                            <a:rPr lang="es-ES" b="1" i="1" smtClean="0">
+                              <a:latin typeface="Cambria Math" panose="02040503050406030204" pitchFamily="18" charset="0"/>
+                            </a:rPr>
+                            <m:t>=</m:t>
+                          </m:r>
+                          <m:r>
+                            <a:rPr lang="es-ES" b="1" i="1" smtClean="0">
+                              <a:latin typeface="Cambria Math" panose="02040503050406030204" pitchFamily="18" charset="0"/>
+                            </a:rPr>
+                            <m:t>𝟎</m:t>
+                          </m:r>
+                          <m:r>
+                            <a:rPr lang="es-ES" b="1" i="1" smtClean="0">
+                              <a:latin typeface="Cambria Math" panose="02040503050406030204" pitchFamily="18" charset="0"/>
+                            </a:rPr>
+                            <m:t>,</m:t>
+                          </m:r>
+                          <m:r>
+                            <a:rPr lang="es-ES" b="1" i="1" smtClean="0">
+                              <a:latin typeface="Cambria Math" panose="02040503050406030204" pitchFamily="18" charset="0"/>
+                            </a:rPr>
+                            <m:t>𝟓</m:t>
+                          </m:r>
+                        </m:e>
+                      </m:d>
+                    </m:oMath>
+                  </m:oMathPara>
+                </a14:m>
+                <a:endParaRPr lang="es-ES" b="1" dirty="0"/>
+              </a:p>
+            </p:txBody>
+          </p:sp>
+        </mc:Choice>
+        <mc:Fallback>
+          <p:sp>
+            <p:nvSpPr>
+              <p:cNvPr id="15" name="TextBox 14">
+                <a:extLst>
+                  <a:ext uri="{FF2B5EF4-FFF2-40B4-BE49-F238E27FC236}">
+                    <a16:creationId xmlns:a16="http://schemas.microsoft.com/office/drawing/2014/main" id="{A4F4FE7F-51DE-202D-D8F8-02FD123F3526}"/>
+                  </a:ext>
+                </a:extLst>
+              </p:cNvPr>
+              <p:cNvSpPr txBox="1">
+                <a:spLocks noRot="1" noChangeAspect="1" noMove="1" noResize="1" noEditPoints="1" noAdjustHandles="1" noChangeArrowheads="1" noChangeShapeType="1" noTextEdit="1"/>
+              </p:cNvSpPr>
+              <p:nvPr/>
+            </p:nvSpPr>
+            <p:spPr>
+              <a:xfrm>
+                <a:off x="3672122" y="1654384"/>
+                <a:ext cx="5395643" cy="276999"/>
+              </a:xfrm>
+              <a:prstGeom prst="rect">
+                <a:avLst/>
+              </a:prstGeom>
+              <a:blipFill>
+                <a:blip r:embed="rId5"/>
+                <a:stretch>
+                  <a:fillRect l="-226" t="-2174" b="-32609"/>
+                </a:stretch>
+              </a:blipFill>
+            </p:spPr>
+            <p:txBody>
+              <a:bodyPr/>
+              <a:lstStyle/>
+              <a:p>
+                <a:r>
+                  <a:rPr lang="es-ES">
+                    <a:noFill/>
+                  </a:rPr>
+                  <a:t> </a:t>
+                </a:r>
+              </a:p>
+            </p:txBody>
+          </p:sp>
+        </mc:Fallback>
+      </mc:AlternateContent>
+      <mc:AlternateContent xmlns:mc="http://schemas.openxmlformats.org/markup-compatibility/2006">
+        <mc:Choice xmlns:a14="http://schemas.microsoft.com/office/drawing/2010/main" Requires="a14">
+          <p:sp>
+            <p:nvSpPr>
+              <p:cNvPr id="16" name="Rectangle: Rounded Corners 15">
+                <a:extLst>
+                  <a:ext uri="{FF2B5EF4-FFF2-40B4-BE49-F238E27FC236}">
+                    <a16:creationId xmlns:a16="http://schemas.microsoft.com/office/drawing/2014/main" id="{FF2AD67C-9575-878A-086A-34AFB5A5070F}"/>
+                  </a:ext>
+                </a:extLst>
+              </p:cNvPr>
+              <p:cNvSpPr/>
+              <p:nvPr/>
+            </p:nvSpPr>
+            <p:spPr>
+              <a:xfrm>
+                <a:off x="179382" y="3117858"/>
+                <a:ext cx="1080000" cy="421200"/>
+              </a:xfrm>
+              <a:prstGeom prst="roundRect">
+                <a:avLst/>
+              </a:prstGeom>
+              <a:solidFill>
+                <a:schemeClr val="accent5"/>
+              </a:solidFill>
+              <a:ln>
+                <a:noFill/>
+              </a:ln>
+              <a:effectLst>
+                <a:outerShdw blurRad="50800" dist="38100" dir="2700000" algn="tl" rotWithShape="0">
+                  <a:prstClr val="black">
+                    <a:alpha val="40000"/>
+                  </a:prstClr>
+                </a:outerShdw>
+              </a:effectLst>
+            </p:spPr>
+            <p:style>
+              <a:lnRef idx="2">
+                <a:schemeClr val="accent1">
+                  <a:shade val="15000"/>
+                </a:schemeClr>
+              </a:lnRef>
+              <a:fillRef idx="1">
+                <a:schemeClr val="accent1"/>
+              </a:fillRef>
+              <a:effectRef idx="0">
+                <a:schemeClr val="accent1"/>
+              </a:effectRef>
+              <a:fontRef idx="minor">
+                <a:schemeClr val="lt1"/>
+              </a:fontRef>
+            </p:style>
+            <p:txBody>
+              <a:bodyPr rtlCol="0" anchor="ctr"/>
+              <a:lstStyle/>
+              <a:p>
+                <a:pPr algn="ctr"/>
+                <a14:m>
+                  <m:oMathPara xmlns:m="http://schemas.openxmlformats.org/officeDocument/2006/math">
+                    <m:oMathParaPr>
+                      <m:jc m:val="centerGroup"/>
+                    </m:oMathParaPr>
+                    <m:oMath xmlns:m="http://schemas.openxmlformats.org/officeDocument/2006/math">
+                      <m:r>
+                        <a:rPr lang="es-ES" b="1" i="1" smtClean="0">
+                          <a:latin typeface="Cambria Math" panose="02040503050406030204" pitchFamily="18" charset="0"/>
+                        </a:rPr>
+                        <m:t>𝝈</m:t>
+                      </m:r>
+                      <m:r>
+                        <a:rPr lang="es-ES" b="1" i="1" smtClean="0">
+                          <a:latin typeface="Cambria Math" panose="02040503050406030204" pitchFamily="18" charset="0"/>
+                        </a:rPr>
+                        <m:t>=</m:t>
+                      </m:r>
+                      <m:r>
+                        <a:rPr lang="es-ES" b="1" i="1" smtClean="0">
+                          <a:latin typeface="Cambria Math" panose="02040503050406030204" pitchFamily="18" charset="0"/>
+                        </a:rPr>
+                        <m:t>𝟒</m:t>
+                      </m:r>
+                    </m:oMath>
+                  </m:oMathPara>
+                </a14:m>
+                <a:endParaRPr lang="es-ES" b="1" dirty="0">
+                  <a:latin typeface="Atkinson Hyperlegible" pitchFamily="2" charset="0"/>
+                </a:endParaRPr>
+              </a:p>
+            </p:txBody>
+          </p:sp>
+        </mc:Choice>
+        <mc:Fallback>
+          <p:sp>
+            <p:nvSpPr>
+              <p:cNvPr id="16" name="Rectangle: Rounded Corners 15">
+                <a:extLst>
+                  <a:ext uri="{FF2B5EF4-FFF2-40B4-BE49-F238E27FC236}">
+                    <a16:creationId xmlns:a16="http://schemas.microsoft.com/office/drawing/2014/main" id="{FF2AD67C-9575-878A-086A-34AFB5A5070F}"/>
+                  </a:ext>
+                </a:extLst>
+              </p:cNvPr>
+              <p:cNvSpPr>
+                <a:spLocks noRot="1" noChangeAspect="1" noMove="1" noResize="1" noEditPoints="1" noAdjustHandles="1" noChangeArrowheads="1" noChangeShapeType="1" noTextEdit="1"/>
+              </p:cNvSpPr>
+              <p:nvPr/>
+            </p:nvSpPr>
+            <p:spPr>
+              <a:xfrm>
+                <a:off x="179382" y="3117858"/>
+                <a:ext cx="1080000" cy="421200"/>
+              </a:xfrm>
+              <a:prstGeom prst="roundRect">
+                <a:avLst/>
+              </a:prstGeom>
+              <a:blipFill>
+                <a:blip r:embed="rId6"/>
+                <a:stretch>
+                  <a:fillRect/>
+                </a:stretch>
+              </a:blipFill>
+              <a:ln>
+                <a:noFill/>
+              </a:ln>
+              <a:effectLst>
+                <a:outerShdw blurRad="50800" dist="38100" dir="2700000" algn="tl" rotWithShape="0">
+                  <a:prstClr val="black">
+                    <a:alpha val="40000"/>
+                  </a:prstClr>
+                </a:outerShdw>
+              </a:effectLst>
+            </p:spPr>
+            <p:txBody>
+              <a:bodyPr/>
+              <a:lstStyle/>
+              <a:p>
+                <a:r>
+                  <a:rPr lang="es-ES">
+                    <a:noFill/>
+                  </a:rPr>
+                  <a:t> </a:t>
+                </a:r>
+              </a:p>
+            </p:txBody>
+          </p:sp>
+        </mc:Fallback>
+      </mc:AlternateContent>
+      <mc:AlternateContent xmlns:mc="http://schemas.openxmlformats.org/markup-compatibility/2006">
+        <mc:Choice xmlns:a14="http://schemas.microsoft.com/office/drawing/2010/main" Requires="a14">
+          <p:sp>
+            <p:nvSpPr>
+              <p:cNvPr id="17" name="Rectangle: Rounded Corners 16">
+                <a:extLst>
+                  <a:ext uri="{FF2B5EF4-FFF2-40B4-BE49-F238E27FC236}">
+                    <a16:creationId xmlns:a16="http://schemas.microsoft.com/office/drawing/2014/main" id="{02B81BB9-14CE-30A2-AB65-E12DA97B296B}"/>
+                  </a:ext>
+                </a:extLst>
+              </p:cNvPr>
+              <p:cNvSpPr/>
+              <p:nvPr/>
+            </p:nvSpPr>
+            <p:spPr>
+              <a:xfrm>
+                <a:off x="3984744" y="3117858"/>
+                <a:ext cx="1080000" cy="421200"/>
+              </a:xfrm>
+              <a:prstGeom prst="roundRect">
+                <a:avLst/>
+              </a:prstGeom>
+              <a:solidFill>
+                <a:schemeClr val="accent5"/>
+              </a:solidFill>
+              <a:ln>
+                <a:noFill/>
+              </a:ln>
+              <a:effectLst>
+                <a:outerShdw blurRad="50800" dist="38100" dir="2700000" algn="tl" rotWithShape="0">
+                  <a:prstClr val="black">
+                    <a:alpha val="40000"/>
+                  </a:prstClr>
+                </a:outerShdw>
+              </a:effectLst>
+            </p:spPr>
+            <p:style>
+              <a:lnRef idx="2">
+                <a:schemeClr val="accent1">
+                  <a:shade val="15000"/>
+                </a:schemeClr>
+              </a:lnRef>
+              <a:fillRef idx="1">
+                <a:schemeClr val="accent1"/>
+              </a:fillRef>
+              <a:effectRef idx="0">
+                <a:schemeClr val="accent1"/>
+              </a:effectRef>
+              <a:fontRef idx="minor">
+                <a:schemeClr val="lt1"/>
+              </a:fontRef>
+            </p:style>
+            <p:txBody>
+              <a:bodyPr rtlCol="0" anchor="ctr"/>
+              <a:lstStyle/>
+              <a:p>
+                <a:pPr algn="ctr"/>
+                <a14:m>
+                  <m:oMathPara xmlns:m="http://schemas.openxmlformats.org/officeDocument/2006/math">
+                    <m:oMathParaPr>
+                      <m:jc m:val="centerGroup"/>
+                    </m:oMathParaPr>
+                    <m:oMath xmlns:m="http://schemas.openxmlformats.org/officeDocument/2006/math">
+                      <m:r>
+                        <a:rPr lang="es-ES" b="1" i="1" smtClean="0">
+                          <a:latin typeface="Cambria Math" panose="02040503050406030204" pitchFamily="18" charset="0"/>
+                        </a:rPr>
+                        <m:t>𝝈</m:t>
+                      </m:r>
+                      <m:r>
+                        <a:rPr lang="es-ES" b="1" i="1" smtClean="0">
+                          <a:latin typeface="Cambria Math" panose="02040503050406030204" pitchFamily="18" charset="0"/>
+                        </a:rPr>
+                        <m:t>=</m:t>
+                      </m:r>
+                      <m:r>
+                        <a:rPr lang="es-ES" b="1" i="1" smtClean="0">
+                          <a:latin typeface="Cambria Math" panose="02040503050406030204" pitchFamily="18" charset="0"/>
+                        </a:rPr>
+                        <m:t>𝟎</m:t>
+                      </m:r>
+                      <m:r>
+                        <a:rPr lang="es-ES" b="1" i="1" smtClean="0">
+                          <a:latin typeface="Cambria Math" panose="02040503050406030204" pitchFamily="18" charset="0"/>
+                        </a:rPr>
+                        <m:t>,</m:t>
+                      </m:r>
+                      <m:r>
+                        <a:rPr lang="es-ES" b="1" i="1" smtClean="0">
+                          <a:latin typeface="Cambria Math" panose="02040503050406030204" pitchFamily="18" charset="0"/>
+                        </a:rPr>
+                        <m:t>𝟓</m:t>
+                      </m:r>
+                    </m:oMath>
+                  </m:oMathPara>
+                </a14:m>
+                <a:endParaRPr lang="es-ES" b="1" dirty="0">
+                  <a:latin typeface="Atkinson Hyperlegible" pitchFamily="2" charset="0"/>
+                </a:endParaRPr>
+              </a:p>
+            </p:txBody>
+          </p:sp>
+        </mc:Choice>
+        <mc:Fallback>
+          <p:sp>
+            <p:nvSpPr>
+              <p:cNvPr id="17" name="Rectangle: Rounded Corners 16">
+                <a:extLst>
+                  <a:ext uri="{FF2B5EF4-FFF2-40B4-BE49-F238E27FC236}">
+                    <a16:creationId xmlns:a16="http://schemas.microsoft.com/office/drawing/2014/main" id="{02B81BB9-14CE-30A2-AB65-E12DA97B296B}"/>
+                  </a:ext>
+                </a:extLst>
+              </p:cNvPr>
+              <p:cNvSpPr>
+                <a:spLocks noRot="1" noChangeAspect="1" noMove="1" noResize="1" noEditPoints="1" noAdjustHandles="1" noChangeArrowheads="1" noChangeShapeType="1" noTextEdit="1"/>
+              </p:cNvSpPr>
+              <p:nvPr/>
+            </p:nvSpPr>
+            <p:spPr>
+              <a:xfrm>
+                <a:off x="3984744" y="3117858"/>
+                <a:ext cx="1080000" cy="421200"/>
+              </a:xfrm>
+              <a:prstGeom prst="roundRect">
+                <a:avLst/>
+              </a:prstGeom>
+              <a:blipFill>
+                <a:blip r:embed="rId7"/>
+                <a:stretch>
+                  <a:fillRect/>
+                </a:stretch>
+              </a:blipFill>
+              <a:ln>
+                <a:noFill/>
+              </a:ln>
+              <a:effectLst>
+                <a:outerShdw blurRad="50800" dist="38100" dir="2700000" algn="tl" rotWithShape="0">
+                  <a:prstClr val="black">
+                    <a:alpha val="40000"/>
+                  </a:prstClr>
+                </a:outerShdw>
+              </a:effectLst>
+            </p:spPr>
+            <p:txBody>
+              <a:bodyPr/>
+              <a:lstStyle/>
+              <a:p>
+                <a:r>
+                  <a:rPr lang="es-ES">
+                    <a:noFill/>
+                  </a:rPr>
+                  <a:t> </a:t>
+                </a:r>
+              </a:p>
+            </p:txBody>
+          </p:sp>
+        </mc:Fallback>
+      </mc:AlternateContent>
+      <mc:AlternateContent xmlns:mc="http://schemas.openxmlformats.org/markup-compatibility/2006">
+        <mc:Choice xmlns:a14="http://schemas.microsoft.com/office/drawing/2010/main" Requires="a14">
+          <p:sp>
+            <p:nvSpPr>
+              <p:cNvPr id="18" name="Rectangle: Rounded Corners 17">
+                <a:extLst>
+                  <a:ext uri="{FF2B5EF4-FFF2-40B4-BE49-F238E27FC236}">
+                    <a16:creationId xmlns:a16="http://schemas.microsoft.com/office/drawing/2014/main" id="{AA085AFF-A4B9-A633-FB0A-4FCC67E0A029}"/>
+                  </a:ext>
+                </a:extLst>
+              </p:cNvPr>
+              <p:cNvSpPr/>
+              <p:nvPr/>
+            </p:nvSpPr>
+            <p:spPr>
+              <a:xfrm>
+                <a:off x="8570605" y="3122481"/>
+                <a:ext cx="1080000" cy="421200"/>
+              </a:xfrm>
+              <a:prstGeom prst="roundRect">
+                <a:avLst/>
+              </a:prstGeom>
+              <a:solidFill>
+                <a:schemeClr val="accent5"/>
+              </a:solidFill>
+              <a:ln>
+                <a:noFill/>
+              </a:ln>
+              <a:effectLst>
+                <a:outerShdw blurRad="50800" dist="38100" dir="2700000" algn="tl" rotWithShape="0">
+                  <a:prstClr val="black">
+                    <a:alpha val="40000"/>
+                  </a:prstClr>
+                </a:outerShdw>
+              </a:effectLst>
+            </p:spPr>
+            <p:style>
+              <a:lnRef idx="2">
+                <a:schemeClr val="accent1">
+                  <a:shade val="15000"/>
+                </a:schemeClr>
+              </a:lnRef>
+              <a:fillRef idx="1">
+                <a:schemeClr val="accent1"/>
+              </a:fillRef>
+              <a:effectRef idx="0">
+                <a:schemeClr val="accent1"/>
+              </a:effectRef>
+              <a:fontRef idx="minor">
+                <a:schemeClr val="lt1"/>
+              </a:fontRef>
+            </p:style>
+            <p:txBody>
+              <a:bodyPr rtlCol="0" anchor="ctr"/>
+              <a:lstStyle/>
+              <a:p>
+                <a:pPr algn="ctr"/>
+                <a14:m>
+                  <m:oMathPara xmlns:m="http://schemas.openxmlformats.org/officeDocument/2006/math">
+                    <m:oMathParaPr>
+                      <m:jc m:val="centerGroup"/>
+                    </m:oMathParaPr>
+                    <m:oMath xmlns:m="http://schemas.openxmlformats.org/officeDocument/2006/math">
+                      <m:r>
+                        <a:rPr lang="es-ES" b="1" i="1" smtClean="0">
+                          <a:latin typeface="Cambria Math" panose="02040503050406030204" pitchFamily="18" charset="0"/>
+                        </a:rPr>
+                        <m:t>𝝈</m:t>
+                      </m:r>
+                      <m:r>
+                        <a:rPr lang="es-ES" b="1" i="1" smtClean="0">
+                          <a:latin typeface="Cambria Math" panose="02040503050406030204" pitchFamily="18" charset="0"/>
+                        </a:rPr>
+                        <m:t>=</m:t>
+                      </m:r>
+                      <m:r>
+                        <a:rPr lang="es-ES" b="1" i="1" smtClean="0">
+                          <a:latin typeface="Cambria Math" panose="02040503050406030204" pitchFamily="18" charset="0"/>
+                        </a:rPr>
+                        <m:t>𝟏</m:t>
+                      </m:r>
+                    </m:oMath>
+                  </m:oMathPara>
+                </a14:m>
+                <a:endParaRPr lang="es-ES" b="1" dirty="0">
+                  <a:latin typeface="Atkinson Hyperlegible" pitchFamily="2" charset="0"/>
+                </a:endParaRPr>
+              </a:p>
+            </p:txBody>
+          </p:sp>
+        </mc:Choice>
+        <mc:Fallback>
+          <p:sp>
+            <p:nvSpPr>
+              <p:cNvPr id="18" name="Rectangle: Rounded Corners 17">
+                <a:extLst>
+                  <a:ext uri="{FF2B5EF4-FFF2-40B4-BE49-F238E27FC236}">
+                    <a16:creationId xmlns:a16="http://schemas.microsoft.com/office/drawing/2014/main" id="{AA085AFF-A4B9-A633-FB0A-4FCC67E0A029}"/>
+                  </a:ext>
+                </a:extLst>
+              </p:cNvPr>
+              <p:cNvSpPr>
+                <a:spLocks noRot="1" noChangeAspect="1" noMove="1" noResize="1" noEditPoints="1" noAdjustHandles="1" noChangeArrowheads="1" noChangeShapeType="1" noTextEdit="1"/>
+              </p:cNvSpPr>
+              <p:nvPr/>
+            </p:nvSpPr>
+            <p:spPr>
+              <a:xfrm>
+                <a:off x="8570605" y="3122481"/>
+                <a:ext cx="1080000" cy="421200"/>
+              </a:xfrm>
+              <a:prstGeom prst="roundRect">
+                <a:avLst/>
+              </a:prstGeom>
+              <a:blipFill>
+                <a:blip r:embed="rId8"/>
+                <a:stretch>
+                  <a:fillRect/>
+                </a:stretch>
+              </a:blipFill>
+              <a:ln>
+                <a:noFill/>
+              </a:ln>
+              <a:effectLst>
+                <a:outerShdw blurRad="50800" dist="38100" dir="2700000" algn="tl" rotWithShape="0">
+                  <a:prstClr val="black">
+                    <a:alpha val="40000"/>
+                  </a:prstClr>
+                </a:outerShdw>
+              </a:effectLst>
+            </p:spPr>
+            <p:txBody>
+              <a:bodyPr/>
+              <a:lstStyle/>
+              <a:p>
+                <a:r>
+                  <a:rPr lang="es-ES">
+                    <a:noFill/>
+                  </a:rPr>
+                  <a:t> </a:t>
+                </a:r>
+              </a:p>
+            </p:txBody>
+          </p:sp>
+        </mc:Fallback>
+      </mc:AlternateContent>
+      <mc:AlternateContent xmlns:mc="http://schemas.openxmlformats.org/markup-compatibility/2006">
+        <mc:Choice xmlns:a14="http://schemas.microsoft.com/office/drawing/2010/main" Requires="a14">
+          <p:sp>
+            <p:nvSpPr>
+              <p:cNvPr id="23" name="TextBox 22">
+                <a:extLst>
+                  <a:ext uri="{FF2B5EF4-FFF2-40B4-BE49-F238E27FC236}">
+                    <a16:creationId xmlns:a16="http://schemas.microsoft.com/office/drawing/2014/main" id="{BBEA968A-BFC8-B13E-3184-52A53C94F350}"/>
+                  </a:ext>
+                </a:extLst>
+              </p:cNvPr>
+              <p:cNvSpPr txBox="1"/>
+              <p:nvPr/>
+            </p:nvSpPr>
+            <p:spPr>
+              <a:xfrm>
+                <a:off x="224288" y="1411017"/>
+                <a:ext cx="2783711" cy="1107996"/>
+              </a:xfrm>
+              <a:prstGeom prst="rect">
+                <a:avLst/>
+              </a:prstGeom>
+              <a:noFill/>
+            </p:spPr>
+            <p:txBody>
+              <a:bodyPr wrap="square" lIns="0" tIns="0" rIns="0" bIns="0" rtlCol="0">
+                <a:spAutoFit/>
+              </a:bodyPr>
+              <a:lstStyle/>
+              <a:p>
+                <a:pPr/>
+                <a14:m>
+                  <m:oMathPara xmlns:m="http://schemas.openxmlformats.org/officeDocument/2006/math">
+                    <m:oMathParaPr>
+                      <m:jc m:val="centerGroup"/>
+                    </m:oMathParaPr>
+                    <m:oMath xmlns:m="http://schemas.openxmlformats.org/officeDocument/2006/math">
+                      <m:sSub>
+                        <m:sSubPr>
+                          <m:ctrlPr>
+                            <a:rPr lang="es-ES" b="1" i="1" smtClean="0">
+                              <a:latin typeface="Cambria Math" panose="02040503050406030204" pitchFamily="18" charset="0"/>
+                            </a:rPr>
+                          </m:ctrlPr>
+                        </m:sSubPr>
+                        <m:e>
+                          <m:r>
+                            <a:rPr lang="es-ES" b="1" i="1" smtClean="0">
+                              <a:latin typeface="Cambria Math" panose="02040503050406030204" pitchFamily="18" charset="0"/>
+                            </a:rPr>
+                            <m:t>𝒘</m:t>
+                          </m:r>
+                        </m:e>
+                        <m:sub>
+                          <m:r>
+                            <a:rPr lang="es-ES" b="1" i="1" smtClean="0">
+                              <a:latin typeface="Cambria Math" panose="02040503050406030204" pitchFamily="18" charset="0"/>
+                            </a:rPr>
+                            <m:t>𝒂</m:t>
+                          </m:r>
+                        </m:sub>
+                      </m:sSub>
+                      <m:r>
+                        <a:rPr lang="es-ES" b="1" i="1" smtClean="0">
+                          <a:latin typeface="Cambria Math" panose="02040503050406030204" pitchFamily="18" charset="0"/>
+                        </a:rPr>
+                        <m:t>  :</m:t>
+                      </m:r>
+                      <m:r>
+                        <m:rPr>
+                          <m:sty m:val="p"/>
+                        </m:rPr>
+                        <a:rPr lang="es-ES" b="0" i="0" smtClean="0">
+                          <a:latin typeface="Cambria Math" panose="02040503050406030204" pitchFamily="18" charset="0"/>
+                        </a:rPr>
+                        <m:t>peso</m:t>
+                      </m:r>
+                      <m:r>
+                        <a:rPr lang="es-ES" b="0" i="0" smtClean="0">
+                          <a:latin typeface="Cambria Math" panose="02040503050406030204" pitchFamily="18" charset="0"/>
+                        </a:rPr>
+                        <m:t> </m:t>
+                      </m:r>
+                      <m:r>
+                        <m:rPr>
+                          <m:sty m:val="p"/>
+                        </m:rPr>
+                        <a:rPr lang="es-ES" b="0" i="0" smtClean="0">
+                          <a:latin typeface="Cambria Math" panose="02040503050406030204" pitchFamily="18" charset="0"/>
+                        </a:rPr>
+                        <m:t>de</m:t>
+                      </m:r>
+                      <m:r>
+                        <a:rPr lang="es-ES" b="0" i="0" smtClean="0">
+                          <a:latin typeface="Cambria Math" panose="02040503050406030204" pitchFamily="18" charset="0"/>
+                        </a:rPr>
+                        <m:t> </m:t>
+                      </m:r>
+                      <m:r>
+                        <m:rPr>
+                          <m:sty m:val="p"/>
+                        </m:rPr>
+                        <a:rPr lang="es-ES" b="0" i="0" smtClean="0">
+                          <a:latin typeface="Cambria Math" panose="02040503050406030204" pitchFamily="18" charset="0"/>
+                        </a:rPr>
+                        <m:t>la</m:t>
+                      </m:r>
+                      <m:r>
+                        <a:rPr lang="es-ES" b="0" i="0" smtClean="0">
+                          <a:latin typeface="Cambria Math" panose="02040503050406030204" pitchFamily="18" charset="0"/>
+                        </a:rPr>
+                        <m:t> </m:t>
+                      </m:r>
+                      <m:r>
+                        <m:rPr>
+                          <m:sty m:val="p"/>
+                        </m:rPr>
+                        <a:rPr lang="es-ES" b="0" i="0" smtClean="0">
+                          <a:latin typeface="Cambria Math" panose="02040503050406030204" pitchFamily="18" charset="0"/>
+                        </a:rPr>
+                        <m:t>poblaci</m:t>
+                      </m:r>
+                      <m:r>
+                        <a:rPr lang="es-ES" b="0" i="0" smtClean="0">
+                          <a:latin typeface="Cambria Math" panose="02040503050406030204" pitchFamily="18" charset="0"/>
+                        </a:rPr>
+                        <m:t>ó</m:t>
+                      </m:r>
+                      <m:r>
+                        <m:rPr>
+                          <m:sty m:val="p"/>
+                        </m:rPr>
+                        <a:rPr lang="es-ES" b="0" i="0" smtClean="0">
+                          <a:latin typeface="Cambria Math" panose="02040503050406030204" pitchFamily="18" charset="0"/>
+                        </a:rPr>
+                        <m:t>n</m:t>
+                      </m:r>
+                      <m:r>
+                        <a:rPr lang="es-ES" b="1" i="1" smtClean="0">
+                          <a:latin typeface="Cambria Math" panose="02040503050406030204" pitchFamily="18" charset="0"/>
+                        </a:rPr>
+                        <m:t> </m:t>
+                      </m:r>
+                      <m:r>
+                        <a:rPr lang="es-ES" b="1" i="1" smtClean="0">
+                          <a:latin typeface="Cambria Math" panose="02040503050406030204" pitchFamily="18" charset="0"/>
+                        </a:rPr>
+                        <m:t>𝒂</m:t>
+                      </m:r>
+                      <m:r>
+                        <a:rPr lang="es-ES" b="1" i="1" smtClean="0">
+                          <a:latin typeface="Cambria Math" panose="02040503050406030204" pitchFamily="18" charset="0"/>
+                        </a:rPr>
+                        <m:t>.</m:t>
+                      </m:r>
+                    </m:oMath>
+                  </m:oMathPara>
+                </a14:m>
+                <a:endParaRPr lang="es-ES" dirty="0">
+                  <a:latin typeface="Cambria Math" panose="02040503050406030204" pitchFamily="18" charset="0"/>
+                </a:endParaRPr>
+              </a:p>
+              <a:p>
+                <a14:m>
+                  <m:oMath xmlns:m="http://schemas.openxmlformats.org/officeDocument/2006/math">
+                    <m:r>
+                      <a:rPr lang="es-ES" b="1" i="1">
+                        <a:latin typeface="Cambria Math" panose="02040503050406030204" pitchFamily="18" charset="0"/>
+                      </a:rPr>
+                      <m:t>𝝓</m:t>
+                    </m:r>
+                    <m:d>
+                      <m:dPr>
+                        <m:ctrlPr>
+                          <a:rPr lang="es-ES" b="1" i="1">
+                            <a:latin typeface="Cambria Math" panose="02040503050406030204" pitchFamily="18" charset="0"/>
+                          </a:rPr>
+                        </m:ctrlPr>
+                      </m:dPr>
+                      <m:e>
+                        <m:r>
+                          <a:rPr lang="es-ES" b="1" i="1">
+                            <a:latin typeface="Cambria Math" panose="02040503050406030204" pitchFamily="18" charset="0"/>
+                          </a:rPr>
+                          <m:t> </m:t>
+                        </m:r>
+                        <m:r>
+                          <a:rPr lang="es-ES" b="1" i="1">
+                            <a:latin typeface="Cambria Math" panose="02040503050406030204" pitchFamily="18" charset="0"/>
+                          </a:rPr>
+                          <m:t>𝑿</m:t>
+                        </m:r>
+                        <m:r>
+                          <a:rPr lang="es-ES" b="1" i="1">
+                            <a:latin typeface="Cambria Math" panose="02040503050406030204" pitchFamily="18" charset="0"/>
+                          </a:rPr>
+                          <m:t>, </m:t>
+                        </m:r>
+                        <m:r>
+                          <a:rPr lang="es-ES" b="1" i="1">
+                            <a:latin typeface="Cambria Math" panose="02040503050406030204" pitchFamily="18" charset="0"/>
+                          </a:rPr>
+                          <m:t>𝝁</m:t>
+                        </m:r>
+                        <m:r>
+                          <a:rPr lang="es-ES" b="1" i="1">
+                            <a:latin typeface="Cambria Math" panose="02040503050406030204" pitchFamily="18" charset="0"/>
+                          </a:rPr>
+                          <m:t>, </m:t>
+                        </m:r>
+                        <m:r>
+                          <a:rPr lang="es-ES" b="1" i="1">
+                            <a:latin typeface="Cambria Math" panose="02040503050406030204" pitchFamily="18" charset="0"/>
+                          </a:rPr>
+                          <m:t>𝝈</m:t>
+                        </m:r>
+                      </m:e>
+                    </m:d>
+                    <m:r>
+                      <a:rPr lang="es-ES" b="1" i="1">
+                        <a:latin typeface="Cambria Math" panose="02040503050406030204" pitchFamily="18" charset="0"/>
+                      </a:rPr>
+                      <m:t> </m:t>
+                    </m:r>
+                  </m:oMath>
+                </a14:m>
+                <a:r>
+                  <a:rPr lang="es-ES" dirty="0">
+                    <a:latin typeface="Cambria Math" panose="02040503050406030204" pitchFamily="18" charset="0"/>
+                  </a:rPr>
+                  <a:t>:función de densidad de una normal.</a:t>
+                </a:r>
+              </a:p>
+              <a:p>
+                <a:endParaRPr lang="es-ES" b="1" i="1" dirty="0">
+                  <a:latin typeface="Cambria Math" panose="02040503050406030204" pitchFamily="18" charset="0"/>
+                </a:endParaRPr>
+              </a:p>
+            </p:txBody>
+          </p:sp>
+        </mc:Choice>
+        <mc:Fallback>
+          <p:sp>
+            <p:nvSpPr>
+              <p:cNvPr id="23" name="TextBox 22">
+                <a:extLst>
+                  <a:ext uri="{FF2B5EF4-FFF2-40B4-BE49-F238E27FC236}">
+                    <a16:creationId xmlns:a16="http://schemas.microsoft.com/office/drawing/2014/main" id="{BBEA968A-BFC8-B13E-3184-52A53C94F350}"/>
+                  </a:ext>
+                </a:extLst>
+              </p:cNvPr>
+              <p:cNvSpPr txBox="1">
+                <a:spLocks noRot="1" noChangeAspect="1" noMove="1" noResize="1" noEditPoints="1" noAdjustHandles="1" noChangeArrowheads="1" noChangeShapeType="1" noTextEdit="1"/>
+              </p:cNvSpPr>
+              <p:nvPr/>
+            </p:nvSpPr>
+            <p:spPr>
+              <a:xfrm>
+                <a:off x="224288" y="1411017"/>
+                <a:ext cx="2783711" cy="1107996"/>
+              </a:xfrm>
+              <a:prstGeom prst="rect">
+                <a:avLst/>
+              </a:prstGeom>
+              <a:blipFill>
+                <a:blip r:embed="rId9"/>
+                <a:stretch>
+                  <a:fillRect l="-5263" t="-549" r="-439"/>
+                </a:stretch>
+              </a:blipFill>
+            </p:spPr>
+            <p:txBody>
+              <a:bodyPr/>
+              <a:lstStyle/>
+              <a:p>
+                <a:r>
+                  <a:rPr lang="es-ES">
+                    <a:noFill/>
+                  </a:rPr>
+                  <a:t> </a:t>
+                </a:r>
+              </a:p>
+            </p:txBody>
+          </p:sp>
+        </mc:Fallback>
+      </mc:AlternateContent>
+      <p:sp>
+        <p:nvSpPr>
+          <p:cNvPr id="24" name="Rectangle 23">
+            <a:extLst>
+              <a:ext uri="{FF2B5EF4-FFF2-40B4-BE49-F238E27FC236}">
+                <a16:creationId xmlns:a16="http://schemas.microsoft.com/office/drawing/2014/main" id="{7E16F0F7-04FE-74BE-DEDC-946D8031FCA2}"/>
+              </a:ext>
+            </a:extLst>
+          </p:cNvPr>
+          <p:cNvSpPr/>
+          <p:nvPr/>
+        </p:nvSpPr>
+        <p:spPr>
+          <a:xfrm>
+            <a:off x="2219417" y="5974672"/>
+            <a:ext cx="2485748" cy="276999"/>
+          </a:xfrm>
+          <a:prstGeom prst="rect">
+            <a:avLst/>
+          </a:prstGeom>
+        </p:spPr>
+        <p:style>
+          <a:lnRef idx="2">
+            <a:schemeClr val="accent1">
+              <a:shade val="15000"/>
+            </a:schemeClr>
+          </a:lnRef>
+          <a:fillRef idx="1">
+            <a:schemeClr val="accent1"/>
+          </a:fillRef>
+          <a:effectRef idx="0">
+            <a:schemeClr val="accent1"/>
+          </a:effectRef>
+          <a:fontRef idx="minor">
+            <a:schemeClr val="lt1"/>
+          </a:fontRef>
+        </p:style>
+        <p:txBody>
+          <a:bodyPr rtlCol="0" anchor="ctr"/>
+          <a:lstStyle/>
+          <a:p>
+            <a:pPr algn="ctr"/>
+            <a:r>
+              <a:rPr lang="es-ES" dirty="0"/>
+              <a:t>En </a:t>
+            </a:r>
+            <a:r>
+              <a:rPr lang="es-ES" dirty="0" err="1"/>
+              <a:t>construccion</a:t>
+            </a:r>
+            <a:endParaRPr lang="es-ES" dirty="0"/>
+          </a:p>
+        </p:txBody>
+      </p:sp>
+    </p:spTree>
+    <p:extLst>
+      <p:ext uri="{BB962C8B-B14F-4D97-AF65-F5344CB8AC3E}">
+        <p14:creationId xmlns:p14="http://schemas.microsoft.com/office/powerpoint/2010/main" val="523683667"/>
+      </p:ext>
+    </p:extLst>
+  </p:cSld>
+  <p:clrMapOvr>
+    <a:masterClrMapping/>
+  </p:clrMapOvr>
+  <p:timing>
+    <p:tnLst>
+      <p:par>
+        <p:cTn id="1" dur="indefinite" restart="never" nodeType="tmRoot">
+          <p:childTnLst>
+            <p:seq concurrent="1" nextAc="seek">
+              <p:cTn id="2" dur="indefinite" nodeType="mainSeq">
+                <p:childTnLst>
+                  <p:par>
+                    <p:cTn id="3" fill="hold">
+                      <p:stCondLst>
+                        <p:cond delay="indefinite"/>
+                      </p:stCondLst>
+                      <p:childTnLst>
+                        <p:par>
+                          <p:cTn id="4" fill="hold">
+                            <p:stCondLst>
+                              <p:cond delay="0"/>
+                            </p:stCondLst>
+                            <p:childTnLst>
+                              <p:par>
+                                <p:cTn id="5" presetID="22" presetClass="entr" presetSubtype="8" fill="hold" grpId="0" nodeType="clickEffect">
+                                  <p:stCondLst>
+                                    <p:cond delay="0"/>
+                                  </p:stCondLst>
+                                  <p:childTnLst>
+                                    <p:set>
+                                      <p:cBhvr>
+                                        <p:cTn id="6" dur="1" fill="hold">
+                                          <p:stCondLst>
+                                            <p:cond delay="0"/>
+                                          </p:stCondLst>
+                                        </p:cTn>
+                                        <p:tgtEl>
+                                          <p:spTgt spid="15"/>
+                                        </p:tgtEl>
+                                        <p:attrNameLst>
+                                          <p:attrName>style.visibility</p:attrName>
+                                        </p:attrNameLst>
+                                      </p:cBhvr>
+                                      <p:to>
+                                        <p:strVal val="visible"/>
+                                      </p:to>
+                                    </p:set>
+                                    <p:animEffect transition="in" filter="wipe(left)">
+                                      <p:cBhvr>
+                                        <p:cTn id="7" dur="500"/>
+                                        <p:tgtEl>
+                                          <p:spTgt spid="15"/>
+                                        </p:tgtEl>
+                                      </p:cBhvr>
+                                    </p:animEffect>
+                                  </p:childTnLst>
+                                </p:cTn>
+                              </p:par>
+                              <p:par>
+                                <p:cTn id="8" presetID="22" presetClass="entr" presetSubtype="8" fill="hold" grpId="0" nodeType="withEffect">
+                                  <p:stCondLst>
+                                    <p:cond delay="0"/>
+                                  </p:stCondLst>
+                                  <p:childTnLst>
+                                    <p:set>
+                                      <p:cBhvr>
+                                        <p:cTn id="9" dur="1" fill="hold">
+                                          <p:stCondLst>
+                                            <p:cond delay="0"/>
+                                          </p:stCondLst>
+                                        </p:cTn>
+                                        <p:tgtEl>
+                                          <p:spTgt spid="23"/>
+                                        </p:tgtEl>
+                                        <p:attrNameLst>
+                                          <p:attrName>style.visibility</p:attrName>
+                                        </p:attrNameLst>
+                                      </p:cBhvr>
+                                      <p:to>
+                                        <p:strVal val="visible"/>
+                                      </p:to>
+                                    </p:set>
+                                    <p:animEffect transition="in" filter="wipe(left)">
+                                      <p:cBhvr>
+                                        <p:cTn id="10" dur="500"/>
+                                        <p:tgtEl>
+                                          <p:spTgt spid="23"/>
+                                        </p:tgtEl>
+                                      </p:cBhvr>
+                                    </p:animEffect>
+                                  </p:childTnLst>
+                                </p:cTn>
+                              </p:par>
+                            </p:childTnLst>
+                          </p:cTn>
+                        </p:par>
+                      </p:childTnLst>
+                    </p:cTn>
+                  </p:par>
+                  <p:par>
+                    <p:cTn id="11" fill="hold">
+                      <p:stCondLst>
+                        <p:cond delay="indefinite"/>
+                      </p:stCondLst>
+                      <p:childTnLst>
+                        <p:par>
+                          <p:cTn id="12" fill="hold">
+                            <p:stCondLst>
+                              <p:cond delay="0"/>
+                            </p:stCondLst>
+                            <p:childTnLst>
+                              <p:par>
+                                <p:cTn id="13" presetID="22" presetClass="entr" presetSubtype="1" fill="hold" grpId="0" nodeType="clickEffect">
+                                  <p:stCondLst>
+                                    <p:cond delay="0"/>
+                                  </p:stCondLst>
+                                  <p:childTnLst>
+                                    <p:set>
+                                      <p:cBhvr>
+                                        <p:cTn id="14" dur="1" fill="hold">
+                                          <p:stCondLst>
+                                            <p:cond delay="0"/>
+                                          </p:stCondLst>
+                                        </p:cTn>
+                                        <p:tgtEl>
+                                          <p:spTgt spid="16"/>
+                                        </p:tgtEl>
+                                        <p:attrNameLst>
+                                          <p:attrName>style.visibility</p:attrName>
+                                        </p:attrNameLst>
+                                      </p:cBhvr>
+                                      <p:to>
+                                        <p:strVal val="visible"/>
+                                      </p:to>
+                                    </p:set>
+                                    <p:animEffect transition="in" filter="wipe(up)">
+                                      <p:cBhvr>
+                                        <p:cTn id="15" dur="500"/>
+                                        <p:tgtEl>
+                                          <p:spTgt spid="16"/>
+                                        </p:tgtEl>
+                                      </p:cBhvr>
+                                    </p:animEffect>
+                                  </p:childTnLst>
+                                </p:cTn>
+                              </p:par>
+                              <p:par>
+                                <p:cTn id="16" presetID="22" presetClass="entr" presetSubtype="1" fill="hold" nodeType="withEffect">
+                                  <p:stCondLst>
+                                    <p:cond delay="0"/>
+                                  </p:stCondLst>
+                                  <p:childTnLst>
+                                    <p:set>
+                                      <p:cBhvr>
+                                        <p:cTn id="17" dur="1" fill="hold">
+                                          <p:stCondLst>
+                                            <p:cond delay="0"/>
+                                          </p:stCondLst>
+                                        </p:cTn>
+                                        <p:tgtEl>
+                                          <p:spTgt spid="10"/>
+                                        </p:tgtEl>
+                                        <p:attrNameLst>
+                                          <p:attrName>style.visibility</p:attrName>
+                                        </p:attrNameLst>
+                                      </p:cBhvr>
+                                      <p:to>
+                                        <p:strVal val="visible"/>
+                                      </p:to>
+                                    </p:set>
+                                    <p:animEffect transition="in" filter="wipe(up)">
+                                      <p:cBhvr>
+                                        <p:cTn id="18" dur="500"/>
+                                        <p:tgtEl>
+                                          <p:spTgt spid="10"/>
+                                        </p:tgtEl>
+                                      </p:cBhvr>
+                                    </p:animEffect>
+                                  </p:childTnLst>
+                                </p:cTn>
+                              </p:par>
+                              <p:par>
+                                <p:cTn id="19" presetID="22" presetClass="entr" presetSubtype="1" fill="hold" grpId="0" nodeType="withEffect">
+                                  <p:stCondLst>
+                                    <p:cond delay="0"/>
+                                  </p:stCondLst>
+                                  <p:childTnLst>
+                                    <p:set>
+                                      <p:cBhvr>
+                                        <p:cTn id="20" dur="1" fill="hold">
+                                          <p:stCondLst>
+                                            <p:cond delay="0"/>
+                                          </p:stCondLst>
+                                        </p:cTn>
+                                        <p:tgtEl>
+                                          <p:spTgt spid="12"/>
+                                        </p:tgtEl>
+                                        <p:attrNameLst>
+                                          <p:attrName>style.visibility</p:attrName>
+                                        </p:attrNameLst>
+                                      </p:cBhvr>
+                                      <p:to>
+                                        <p:strVal val="visible"/>
+                                      </p:to>
+                                    </p:set>
+                                    <p:animEffect transition="in" filter="wipe(up)">
+                                      <p:cBhvr>
+                                        <p:cTn id="21" dur="500"/>
+                                        <p:tgtEl>
+                                          <p:spTgt spid="12"/>
+                                        </p:tgtEl>
+                                      </p:cBhvr>
+                                    </p:animEffect>
+                                  </p:childTnLst>
+                                </p:cTn>
+                              </p:par>
+                              <p:par>
+                                <p:cTn id="22" presetID="22" presetClass="entr" presetSubtype="1" fill="hold" grpId="0" nodeType="withEffect">
+                                  <p:stCondLst>
+                                    <p:cond delay="0"/>
+                                  </p:stCondLst>
+                                  <p:childTnLst>
+                                    <p:set>
+                                      <p:cBhvr>
+                                        <p:cTn id="23" dur="1" fill="hold">
+                                          <p:stCondLst>
+                                            <p:cond delay="0"/>
+                                          </p:stCondLst>
+                                        </p:cTn>
+                                        <p:tgtEl>
+                                          <p:spTgt spid="17"/>
+                                        </p:tgtEl>
+                                        <p:attrNameLst>
+                                          <p:attrName>style.visibility</p:attrName>
+                                        </p:attrNameLst>
+                                      </p:cBhvr>
+                                      <p:to>
+                                        <p:strVal val="visible"/>
+                                      </p:to>
+                                    </p:set>
+                                    <p:animEffect transition="in" filter="wipe(up)">
+                                      <p:cBhvr>
+                                        <p:cTn id="24" dur="500"/>
+                                        <p:tgtEl>
+                                          <p:spTgt spid="17"/>
+                                        </p:tgtEl>
+                                      </p:cBhvr>
+                                    </p:animEffect>
+                                  </p:childTnLst>
+                                </p:cTn>
+                              </p:par>
+                              <p:par>
+                                <p:cTn id="25" presetID="22" presetClass="entr" presetSubtype="1" fill="hold" nodeType="withEffect">
+                                  <p:stCondLst>
+                                    <p:cond delay="0"/>
+                                  </p:stCondLst>
+                                  <p:childTnLst>
+                                    <p:set>
+                                      <p:cBhvr>
+                                        <p:cTn id="26" dur="1" fill="hold">
+                                          <p:stCondLst>
+                                            <p:cond delay="0"/>
+                                          </p:stCondLst>
+                                        </p:cTn>
+                                        <p:tgtEl>
+                                          <p:spTgt spid="11"/>
+                                        </p:tgtEl>
+                                        <p:attrNameLst>
+                                          <p:attrName>style.visibility</p:attrName>
+                                        </p:attrNameLst>
+                                      </p:cBhvr>
+                                      <p:to>
+                                        <p:strVal val="visible"/>
+                                      </p:to>
+                                    </p:set>
+                                    <p:animEffect transition="in" filter="wipe(up)">
+                                      <p:cBhvr>
+                                        <p:cTn id="27" dur="500"/>
+                                        <p:tgtEl>
+                                          <p:spTgt spid="11"/>
+                                        </p:tgtEl>
+                                      </p:cBhvr>
+                                    </p:animEffect>
+                                  </p:childTnLst>
+                                </p:cTn>
+                              </p:par>
+                              <p:par>
+                                <p:cTn id="28" presetID="22" presetClass="entr" presetSubtype="1" fill="hold" grpId="0" nodeType="withEffect">
+                                  <p:stCondLst>
+                                    <p:cond delay="0"/>
+                                  </p:stCondLst>
+                                  <p:childTnLst>
+                                    <p:set>
+                                      <p:cBhvr>
+                                        <p:cTn id="29" dur="1" fill="hold">
+                                          <p:stCondLst>
+                                            <p:cond delay="0"/>
+                                          </p:stCondLst>
+                                        </p:cTn>
+                                        <p:tgtEl>
+                                          <p:spTgt spid="14"/>
+                                        </p:tgtEl>
+                                        <p:attrNameLst>
+                                          <p:attrName>style.visibility</p:attrName>
+                                        </p:attrNameLst>
+                                      </p:cBhvr>
+                                      <p:to>
+                                        <p:strVal val="visible"/>
+                                      </p:to>
+                                    </p:set>
+                                    <p:animEffect transition="in" filter="wipe(up)">
+                                      <p:cBhvr>
+                                        <p:cTn id="30" dur="500"/>
+                                        <p:tgtEl>
+                                          <p:spTgt spid="14"/>
+                                        </p:tgtEl>
+                                      </p:cBhvr>
+                                    </p:animEffect>
+                                  </p:childTnLst>
+                                </p:cTn>
+                              </p:par>
+                              <p:par>
+                                <p:cTn id="31" presetID="22" presetClass="entr" presetSubtype="1" fill="hold" grpId="0" nodeType="withEffect">
+                                  <p:stCondLst>
+                                    <p:cond delay="0"/>
+                                  </p:stCondLst>
+                                  <p:childTnLst>
+                                    <p:set>
+                                      <p:cBhvr>
+                                        <p:cTn id="32" dur="1" fill="hold">
+                                          <p:stCondLst>
+                                            <p:cond delay="0"/>
+                                          </p:stCondLst>
+                                        </p:cTn>
+                                        <p:tgtEl>
+                                          <p:spTgt spid="13"/>
+                                        </p:tgtEl>
+                                        <p:attrNameLst>
+                                          <p:attrName>style.visibility</p:attrName>
+                                        </p:attrNameLst>
+                                      </p:cBhvr>
+                                      <p:to>
+                                        <p:strVal val="visible"/>
+                                      </p:to>
+                                    </p:set>
+                                    <p:animEffect transition="in" filter="wipe(up)">
+                                      <p:cBhvr>
+                                        <p:cTn id="33" dur="500"/>
+                                        <p:tgtEl>
+                                          <p:spTgt spid="13"/>
+                                        </p:tgtEl>
+                                      </p:cBhvr>
+                                    </p:animEffect>
+                                  </p:childTnLst>
+                                </p:cTn>
+                              </p:par>
+                              <p:par>
+                                <p:cTn id="34" presetID="22" presetClass="entr" presetSubtype="1" fill="hold" grpId="0" nodeType="withEffect">
+                                  <p:stCondLst>
+                                    <p:cond delay="0"/>
+                                  </p:stCondLst>
+                                  <p:childTnLst>
+                                    <p:set>
+                                      <p:cBhvr>
+                                        <p:cTn id="35" dur="1" fill="hold">
+                                          <p:stCondLst>
+                                            <p:cond delay="0"/>
+                                          </p:stCondLst>
+                                        </p:cTn>
+                                        <p:tgtEl>
+                                          <p:spTgt spid="18"/>
+                                        </p:tgtEl>
+                                        <p:attrNameLst>
+                                          <p:attrName>style.visibility</p:attrName>
+                                        </p:attrNameLst>
+                                      </p:cBhvr>
+                                      <p:to>
+                                        <p:strVal val="visible"/>
+                                      </p:to>
+                                    </p:set>
+                                    <p:animEffect transition="in" filter="wipe(up)">
+                                      <p:cBhvr>
+                                        <p:cTn id="36" dur="500"/>
+                                        <p:tgtEl>
+                                          <p:spTgt spid="18"/>
+                                        </p:tgtEl>
+                                      </p:cBhvr>
+                                    </p:animEffect>
+                                  </p:childTnLst>
+                                </p:cTn>
+                              </p:par>
+                              <p:par>
+                                <p:cTn id="37" presetID="22" presetClass="entr" presetSubtype="1" fill="hold" nodeType="withEffect">
+                                  <p:stCondLst>
+                                    <p:cond delay="0"/>
+                                  </p:stCondLst>
+                                  <p:childTnLst>
+                                    <p:set>
+                                      <p:cBhvr>
+                                        <p:cTn id="38" dur="1" fill="hold">
+                                          <p:stCondLst>
+                                            <p:cond delay="0"/>
+                                          </p:stCondLst>
+                                        </p:cTn>
+                                        <p:tgtEl>
+                                          <p:spTgt spid="9"/>
+                                        </p:tgtEl>
+                                        <p:attrNameLst>
+                                          <p:attrName>style.visibility</p:attrName>
+                                        </p:attrNameLst>
+                                      </p:cBhvr>
+                                      <p:to>
+                                        <p:strVal val="visible"/>
+                                      </p:to>
+                                    </p:set>
+                                    <p:animEffect transition="in" filter="wipe(up)">
+                                      <p:cBhvr>
+                                        <p:cTn id="39" dur="500"/>
+                                        <p:tgtEl>
+                                          <p:spTgt spid="9"/>
+                                        </p:tgtEl>
+                                      </p:cBhvr>
+                                    </p:animEffect>
+                                  </p:childTnLst>
+                                </p:cTn>
+                              </p:par>
+                            </p:childTnLst>
+                          </p:cTn>
+                        </p:par>
+                      </p:childTnLst>
+                    </p:cTn>
+                  </p:par>
+                </p:childTnLst>
+              </p:cTn>
+              <p:prevCondLst>
+                <p:cond evt="onPrev" delay="0">
+                  <p:tgtEl>
+                    <p:sldTgt/>
+                  </p:tgtEl>
+                </p:cond>
+              </p:prevCondLst>
+              <p:nextCondLst>
+                <p:cond evt="onNext" delay="0">
+                  <p:tgtEl>
+                    <p:sldTgt/>
+                  </p:tgtEl>
+                </p:cond>
+              </p:nextCondLst>
+            </p:seq>
+          </p:childTnLst>
+        </p:cTn>
+      </p:par>
+    </p:tnLst>
+    <p:bldLst>
+      <p:bldP spid="12" grpId="0" animBg="1"/>
+      <p:bldP spid="13" grpId="0" animBg="1"/>
+      <p:bldP spid="14" grpId="0" animBg="1"/>
+      <p:bldP spid="15" grpId="0"/>
+      <p:bldP spid="16" grpId="0" animBg="1"/>
+      <p:bldP spid="17" grpId="0" animBg="1"/>
+      <p:bldP spid="18" grpId="0" animBg="1"/>
+      <p:bldP spid="23" grpId="0"/>
+    </p:bldLst>
+  </p:timing>
+</p:sld>
+</file>
+
+<file path=ppt/slides/slide16.xml><?xml version="1.0" encoding="utf-8"?>
+<p:sld xmlns:a="http://schemas.openxmlformats.org/drawingml/2006/main" xmlns:r="http://schemas.openxmlformats.org/officeDocument/2006/relationships" xmlns:p="http://schemas.openxmlformats.org/presentationml/2006/main">
+  <p:cSld>
+    <p:spTree>
+      <p:nvGrpSpPr>
         <p:cNvPr id="1" name="">
           <a:extLst>
             <a:ext uri="{FF2B5EF4-FFF2-40B4-BE49-F238E27FC236}">
@@ -6140,7 +8144,7 @@
 </p:sld>
 </file>
 
-<file path=ppt/slides/slide16.xml><?xml version="1.0" encoding="utf-8"?>
+<file path=ppt/slides/slide17.xml><?xml version="1.0" encoding="utf-8"?>
 <p:sld xmlns:a="http://schemas.openxmlformats.org/drawingml/2006/main" xmlns:r="http://schemas.openxmlformats.org/officeDocument/2006/relationships" xmlns:p="http://schemas.openxmlformats.org/presentationml/2006/main">
   <p:cSld>
     <p:spTree>
@@ -6375,7 +8379,7 @@
 </p:sld>
 </file>
 
-<file path=ppt/slides/slide17.xml><?xml version="1.0" encoding="utf-8"?>
+<file path=ppt/slides/slide18.xml><?xml version="1.0" encoding="utf-8"?>
 <p:sld xmlns:a="http://schemas.openxmlformats.org/drawingml/2006/main" xmlns:r="http://schemas.openxmlformats.org/officeDocument/2006/relationships" xmlns:p="http://schemas.openxmlformats.org/presentationml/2006/main">
   <p:cSld>
     <p:spTree>
@@ -11823,8 +13827,8 @@
           </a:p>
         </p:txBody>
       </p:sp>
-      <mc:AlternateContent xmlns:mc="http://schemas.openxmlformats.org/markup-compatibility/2006">
-        <mc:Choice xmlns:a14="http://schemas.microsoft.com/office/drawing/2010/main" Requires="a14">
+      <mc:AlternateContent xmlns:mc="http://schemas.openxmlformats.org/markup-compatibility/2006" xmlns:a14="http://schemas.microsoft.com/office/drawing/2010/main">
+        <mc:Choice Requires="a14">
           <p:sp>
             <p:nvSpPr>
               <p:cNvPr id="18" name="TextBox 17">
@@ -11853,6 +13857,7 @@
               </a:bodyPr>
               <a:lstStyle/>
               <a:p>
+                <a:pPr/>
                 <a14:m>
                   <m:oMathPara xmlns:m="http://schemas.openxmlformats.org/officeDocument/2006/math">
                     <m:oMathParaPr>
@@ -11897,11 +13902,12 @@
                     </m:oMath>
                   </m:oMathPara>
                 </a14:m>
+                <a:endParaRPr/>
               </a:p>
             </p:txBody>
           </p:sp>
         </mc:Choice>
-        <mc:Fallback>
+        <mc:Fallback xmlns="">
           <p:sp>
             <p:nvSpPr>
               <p:cNvPr id="18" name="TextBox 17">
@@ -11946,8 +13952,8 @@
           </p:sp>
         </mc:Fallback>
       </mc:AlternateContent>
-      <mc:AlternateContent xmlns:mc="http://schemas.openxmlformats.org/markup-compatibility/2006">
-        <mc:Choice xmlns:a14="http://schemas.microsoft.com/office/drawing/2010/main" Requires="a14">
+      <mc:AlternateContent xmlns:mc="http://schemas.openxmlformats.org/markup-compatibility/2006" xmlns:a14="http://schemas.microsoft.com/office/drawing/2010/main">
+        <mc:Choice Requires="a14">
           <p:sp>
             <p:nvSpPr>
               <p:cNvPr id="19" name="TextBox 18">
@@ -11976,6 +13982,7 @@
               </a:bodyPr>
               <a:lstStyle/>
               <a:p>
+                <a:pPr/>
                 <a14:m>
                   <m:oMathPara xmlns:m="http://schemas.openxmlformats.org/officeDocument/2006/math">
                     <m:oMathParaPr>
@@ -12020,11 +14027,12 @@
                     </m:oMath>
                   </m:oMathPara>
                 </a14:m>
+                <a:endParaRPr/>
               </a:p>
             </p:txBody>
           </p:sp>
         </mc:Choice>
-        <mc:Fallback>
+        <mc:Fallback xmlns="">
           <p:sp>
             <p:nvSpPr>
               <p:cNvPr id="19" name="TextBox 18">
@@ -12069,8 +14077,8 @@
           </p:sp>
         </mc:Fallback>
       </mc:AlternateContent>
-      <mc:AlternateContent xmlns:mc="http://schemas.openxmlformats.org/markup-compatibility/2006">
-        <mc:Choice xmlns:a14="http://schemas.microsoft.com/office/drawing/2010/main" Requires="a14">
+      <mc:AlternateContent xmlns:mc="http://schemas.openxmlformats.org/markup-compatibility/2006" xmlns:a14="http://schemas.microsoft.com/office/drawing/2010/main">
+        <mc:Choice Requires="a14">
           <p:sp>
             <p:nvSpPr>
               <p:cNvPr id="20" name="TextBox 19">
@@ -12099,6 +14107,7 @@
               </a:bodyPr>
               <a:lstStyle/>
               <a:p>
+                <a:pPr/>
                 <a14:m>
                   <m:oMathPara xmlns:m="http://schemas.openxmlformats.org/officeDocument/2006/math">
                     <m:oMathParaPr>
@@ -12143,11 +14152,12 @@
                     </m:oMath>
                   </m:oMathPara>
                 </a14:m>
+                <a:endParaRPr/>
               </a:p>
             </p:txBody>
           </p:sp>
         </mc:Choice>
-        <mc:Fallback>
+        <mc:Fallback xmlns="">
           <p:sp>
             <p:nvSpPr>
               <p:cNvPr id="20" name="TextBox 19">
@@ -13071,8 +15081,8 @@
           </a:p>
         </p:txBody>
       </p:sp>
-      <mc:AlternateContent xmlns:mc="http://schemas.openxmlformats.org/markup-compatibility/2006">
-        <mc:Choice xmlns:a14="http://schemas.microsoft.com/office/drawing/2010/main" Requires="a14">
+      <mc:AlternateContent xmlns:mc="http://schemas.openxmlformats.org/markup-compatibility/2006" xmlns:a14="http://schemas.microsoft.com/office/drawing/2010/main">
+        <mc:Choice Requires="a14">
           <p:sp>
             <p:nvSpPr>
               <p:cNvPr id="48" name="TextBox 47">
@@ -13227,6 +15237,7 @@
                 </a:r>
               </a:p>
               <a:p>
+                <a:pPr/>
                 <a14:m>
                   <m:oMathPara xmlns:m="http://schemas.openxmlformats.org/officeDocument/2006/math">
                     <m:oMathParaPr>
@@ -13290,6 +15301,7 @@
                 </a:endParaRPr>
               </a:p>
               <a:p>
+                <a:pPr/>
                 <a14:m>
                   <m:oMathPara xmlns:m="http://schemas.openxmlformats.org/officeDocument/2006/math">
                     <m:oMathParaPr>
@@ -13386,7 +15398,7 @@
             </p:txBody>
           </p:sp>
         </mc:Choice>
-        <mc:Fallback>
+        <mc:Fallback xmlns="">
           <p:sp>
             <p:nvSpPr>
               <p:cNvPr id="48" name="TextBox 47">

</xml_diff>